<commit_message>
feat: Upgrade dashboard UI to modern millennial aesthetics, strict 7-dimension cross-filtering, branch merging rules, and robust ES module initialization
</commit_message>
<xml_diff>
--- a/backend/generated_mtm_report.pptx
+++ b/backend/generated_mtm_report.pptx
@@ -5505,6 +5505,65 @@
           </a:p>
         </p:txBody>
       </p:sp>
+      <p:sp>
+        <p:nvSpPr>
+          <p:cNvPr id="56" name="TextBox 55"/>
+          <p:cNvSpPr txBox="1"/>
+          <p:nvPr/>
+        </p:nvSpPr>
+        <p:spPr>
+          <a:xfrm>
+            <a:off x="731520" y="3474720"/>
+            <a:ext cx="7772400" cy="1371600"/>
+          </a:xfrm>
+          <a:prstGeom prst="rect">
+            <a:avLst/>
+          </a:prstGeom>
+          <a:noFill/>
+        </p:spPr>
+        <p:txBody>
+          <a:bodyPr wrap="square">
+            <a:spAutoFit/>
+          </a:bodyPr>
+          <a:lstStyle/>
+          <a:p>
+            <a:pPr>
+              <a:defRPr sz="2000" b="1">
+                <a:solidFill>
+                  <a:srgbClr val="FFFFFF"/>
+                </a:solidFill>
+              </a:defRPr>
+            </a:pPr>
+            <a:r>
+              <a:t>LAPORAN EXECUTIVE SERVICE LEVEL MTM</a:t>
+            </a:r>
+          </a:p>
+          <a:p>
+            <a:pPr>
+              <a:defRPr sz="1300">
+                <a:solidFill>
+                  <a:srgbClr val="FFD700"/>
+                </a:solidFill>
+              </a:defRPr>
+            </a:pPr>
+            <a:r>
+              <a:t>Analisis Performa Pengiriman, Realisasi, dan Pareto Unfulfill</a:t>
+            </a:r>
+          </a:p>
+          <a:p>
+            <a:pPr>
+              <a:defRPr sz="1100" b="1">
+                <a:solidFill>
+                  <a:srgbClr val="F8FAFC"/>
+                </a:solidFill>
+              </a:defRPr>
+            </a:pPr>
+            <a:r>
+              <a:t>PERIODE FILTER: AGU-2026 | JENIS MTM: KA | CABANG: Semua Cabang</a:t>
+            </a:r>
+          </a:p>
+        </p:txBody>
+      </p:sp>
     </p:spTree>
   </p:cSld>
   <p:clrMapOvr>
@@ -5568,6 +5627,1009 @@
           </a:p>
         </p:txBody>
       </p:sp>
+      <p:sp>
+        <p:nvSpPr>
+          <p:cNvPr id="6" name="TextBox 5"/>
+          <p:cNvSpPr txBox="1"/>
+          <p:nvPr/>
+        </p:nvSpPr>
+        <p:spPr>
+          <a:xfrm>
+            <a:off x="548640" y="914400"/>
+            <a:ext cx="8046720" cy="548640"/>
+          </a:xfrm>
+          <a:prstGeom prst="rect">
+            <a:avLst/>
+          </a:prstGeom>
+          <a:noFill/>
+        </p:spPr>
+        <p:txBody>
+          <a:bodyPr wrap="square">
+            <a:spAutoFit/>
+          </a:bodyPr>
+          <a:lstStyle/>
+          <a:p>
+            <a:pPr>
+              <a:defRPr sz="1700" b="1">
+                <a:solidFill>
+                  <a:srgbClr val="C00000"/>
+                </a:solidFill>
+              </a:defRPr>
+            </a:pPr>
+            <a:r>
+              <a:t>1. EXECUTIVE KPI SUMMARY &amp; TREND (AGU-2026)</a:t>
+            </a:r>
+          </a:p>
+          <a:p>
+            <a:pPr>
+              <a:defRPr sz="850" b="1">
+                <a:solidFill>
+                  <a:srgbClr val="646464"/>
+                </a:solidFill>
+              </a:defRPr>
+            </a:pPr>
+            <a:r>
+              <a:t>📌 Filter Aktif: Bulan = AGU-2026 | MTM = KA | Cabang = Semua Cabang | Brand = Semua Grup Brand</a:t>
+            </a:r>
+          </a:p>
+        </p:txBody>
+      </p:sp>
+      <p:sp>
+        <p:nvSpPr>
+          <p:cNvPr id="7" name="Rounded Rectangle 6"/>
+          <p:cNvSpPr/>
+          <p:nvPr/>
+        </p:nvSpPr>
+        <p:spPr>
+          <a:xfrm>
+            <a:off x="548640" y="1554480"/>
+            <a:ext cx="2468880" cy="1051560"/>
+          </a:xfrm>
+          <a:prstGeom prst="roundRect">
+            <a:avLst/>
+          </a:prstGeom>
+          <a:solidFill>
+            <a:srgbClr val="F8F9FA"/>
+          </a:solidFill>
+          <a:ln>
+            <a:solidFill>
+              <a:srgbClr val="C00000"/>
+            </a:solidFill>
+          </a:ln>
+        </p:spPr>
+        <p:style>
+          <a:lnRef idx="1">
+            <a:schemeClr val="accent1"/>
+          </a:lnRef>
+          <a:fillRef idx="3">
+            <a:schemeClr val="accent1"/>
+          </a:fillRef>
+          <a:effectRef idx="2">
+            <a:schemeClr val="accent1"/>
+          </a:effectRef>
+          <a:fontRef idx="minor">
+            <a:schemeClr val="lt1"/>
+          </a:fontRef>
+        </p:style>
+        <p:txBody>
+          <a:bodyPr rtlCol="0" anchor="ctr" wrap="square"/>
+          <a:lstStyle/>
+          <a:p>
+            <a:pPr algn="ctr">
+              <a:defRPr sz="950" b="1">
+                <a:solidFill>
+                  <a:srgbClr val="646464"/>
+                </a:solidFill>
+              </a:defRPr>
+            </a:pPr>
+            <a:r>
+              <a:t>SERVICE LEVEL KIRIM</a:t>
+            </a:r>
+          </a:p>
+          <a:p>
+            <a:pPr algn="ctr">
+              <a:defRPr sz="2100" b="1">
+                <a:solidFill>
+                  <a:srgbClr val="C00000"/>
+                </a:solidFill>
+              </a:defRPr>
+            </a:pPr>
+            <a:r>
+              <a:t>87.6%</a:t>
+            </a:r>
+          </a:p>
+          <a:p>
+            <a:pPr algn="ctr">
+              <a:defRPr sz="800">
+                <a:solidFill>
+                  <a:srgbClr val="787878"/>
+                </a:solidFill>
+              </a:defRPr>
+            </a:pPr>
+            <a:r>
+              <a:t>Target Acuan: 85.0%</a:t>
+            </a:r>
+          </a:p>
+        </p:txBody>
+      </p:sp>
+      <p:sp>
+        <p:nvSpPr>
+          <p:cNvPr id="8" name="Rounded Rectangle 7"/>
+          <p:cNvSpPr/>
+          <p:nvPr/>
+        </p:nvSpPr>
+        <p:spPr>
+          <a:xfrm>
+            <a:off x="3337560" y="1554480"/>
+            <a:ext cx="2468880" cy="1051560"/>
+          </a:xfrm>
+          <a:prstGeom prst="roundRect">
+            <a:avLst/>
+          </a:prstGeom>
+          <a:solidFill>
+            <a:srgbClr val="F8F9FA"/>
+          </a:solidFill>
+          <a:ln>
+            <a:solidFill>
+              <a:srgbClr val="C00000"/>
+            </a:solidFill>
+          </a:ln>
+        </p:spPr>
+        <p:style>
+          <a:lnRef idx="1">
+            <a:schemeClr val="accent1"/>
+          </a:lnRef>
+          <a:fillRef idx="3">
+            <a:schemeClr val="accent1"/>
+          </a:fillRef>
+          <a:effectRef idx="2">
+            <a:schemeClr val="accent1"/>
+          </a:effectRef>
+          <a:fontRef idx="minor">
+            <a:schemeClr val="lt1"/>
+          </a:fontRef>
+        </p:style>
+        <p:txBody>
+          <a:bodyPr rtlCol="0" anchor="ctr" wrap="square"/>
+          <a:lstStyle/>
+          <a:p>
+            <a:pPr algn="ctr">
+              <a:defRPr sz="950" b="1">
+                <a:solidFill>
+                  <a:srgbClr val="646464"/>
+                </a:solidFill>
+              </a:defRPr>
+            </a:pPr>
+            <a:r>
+              <a:t>SERVICE LEVEL REALISASI</a:t>
+            </a:r>
+          </a:p>
+          <a:p>
+            <a:pPr algn="ctr">
+              <a:defRPr sz="2100" b="1">
+                <a:solidFill>
+                  <a:srgbClr val="C00000"/>
+                </a:solidFill>
+              </a:defRPr>
+            </a:pPr>
+            <a:r>
+              <a:t>52.9%</a:t>
+            </a:r>
+          </a:p>
+          <a:p>
+            <a:pPr algn="ctr">
+              <a:defRPr sz="800">
+                <a:solidFill>
+                  <a:srgbClr val="787878"/>
+                </a:solidFill>
+              </a:defRPr>
+            </a:pPr>
+            <a:r>
+              <a:t>Target Acuan: 85.0%</a:t>
+            </a:r>
+          </a:p>
+        </p:txBody>
+      </p:sp>
+      <p:sp>
+        <p:nvSpPr>
+          <p:cNvPr id="9" name="Rounded Rectangle 8"/>
+          <p:cNvSpPr/>
+          <p:nvPr/>
+        </p:nvSpPr>
+        <p:spPr>
+          <a:xfrm>
+            <a:off x="6126480" y="1554480"/>
+            <a:ext cx="2468880" cy="1051560"/>
+          </a:xfrm>
+          <a:prstGeom prst="roundRect">
+            <a:avLst/>
+          </a:prstGeom>
+          <a:solidFill>
+            <a:srgbClr val="F8F9FA"/>
+          </a:solidFill>
+          <a:ln>
+            <a:solidFill>
+              <a:srgbClr val="C00000"/>
+            </a:solidFill>
+          </a:ln>
+        </p:spPr>
+        <p:style>
+          <a:lnRef idx="1">
+            <a:schemeClr val="accent1"/>
+          </a:lnRef>
+          <a:fillRef idx="3">
+            <a:schemeClr val="accent1"/>
+          </a:fillRef>
+          <a:effectRef idx="2">
+            <a:schemeClr val="accent1"/>
+          </a:effectRef>
+          <a:fontRef idx="minor">
+            <a:schemeClr val="lt1"/>
+          </a:fontRef>
+        </p:style>
+        <p:txBody>
+          <a:bodyPr rtlCol="0" anchor="ctr" wrap="square"/>
+          <a:lstStyle/>
+          <a:p>
+            <a:pPr algn="ctr">
+              <a:defRPr sz="950" b="1">
+                <a:solidFill>
+                  <a:srgbClr val="646464"/>
+                </a:solidFill>
+              </a:defRPr>
+            </a:pPr>
+            <a:r>
+              <a:t>GAP REALISASI VS KIRIM</a:t>
+            </a:r>
+          </a:p>
+          <a:p>
+            <a:pPr algn="ctr">
+              <a:defRPr sz="2100" b="1">
+                <a:solidFill>
+                  <a:srgbClr val="EF4444"/>
+                </a:solidFill>
+              </a:defRPr>
+            </a:pPr>
+            <a:r>
+              <a:t>-34.7%</a:t>
+            </a:r>
+          </a:p>
+          <a:p>
+            <a:pPr algn="ctr">
+              <a:defRPr sz="800">
+                <a:solidFill>
+                  <a:srgbClr val="787878"/>
+                </a:solidFill>
+              </a:defRPr>
+            </a:pPr>
+            <a:r>
+              <a:t>Selisih Performa</a:t>
+            </a:r>
+          </a:p>
+        </p:txBody>
+      </p:sp>
+      <p:graphicFrame>
+        <p:nvGraphicFramePr>
+          <p:cNvPr id="10" name="Table 9"/>
+          <p:cNvGraphicFramePr>
+            <a:graphicFrameLocks noGrp="1"/>
+          </p:cNvGraphicFramePr>
+          <p:nvPr/>
+        </p:nvGraphicFramePr>
+        <p:xfrm>
+          <a:off x="548640" y="2788920"/>
+          <a:ext cx="8046720" cy="1737360"/>
+        </p:xfrm>
+        <a:graphic>
+          <a:graphicData uri="http://schemas.openxmlformats.org/drawingml/2006/table">
+            <a:tbl>
+              <a:tblPr firstRow="1" bandRow="1">
+                <a:tableStyleId>{5C22544A-7EE6-4342-B048-85BDC9FD1C3A}</a:tableStyleId>
+              </a:tblPr>
+              <a:tblGrid>
+                <a:gridCol w="1341120"/>
+                <a:gridCol w="1341120"/>
+                <a:gridCol w="1341120"/>
+                <a:gridCol w="1341120"/>
+                <a:gridCol w="1341120"/>
+                <a:gridCol w="1341120"/>
+              </a:tblGrid>
+              <a:tr h="248194">
+                <a:tc>
+                  <a:txBody>
+                    <a:bodyPr/>
+                    <a:lstStyle/>
+                    <a:p>
+                      <a:pPr algn="ctr">
+                        <a:defRPr b="1" sz="900">
+                          <a:solidFill>
+                            <a:srgbClr val="FFFFFF"/>
+                          </a:solidFill>
+                        </a:defRPr>
+                      </a:pPr>
+                      <a:r>
+                        <a:t>Bulan</a:t>
+                      </a:r>
+                    </a:p>
+                  </a:txBody>
+                  <a:tcPr>
+                    <a:solidFill>
+                      <a:srgbClr val="C00000"/>
+                    </a:solidFill>
+                  </a:tcPr>
+                </a:tc>
+                <a:tc>
+                  <a:txBody>
+                    <a:bodyPr/>
+                    <a:lstStyle/>
+                    <a:p>
+                      <a:pPr algn="ctr">
+                        <a:defRPr b="1" sz="900">
+                          <a:solidFill>
+                            <a:srgbClr val="FFFFFF"/>
+                          </a:solidFill>
+                        </a:defRPr>
+                      </a:pPr>
+                      <a:r>
+                        <a:t>Total Pesan</a:t>
+                      </a:r>
+                    </a:p>
+                  </a:txBody>
+                  <a:tcPr>
+                    <a:solidFill>
+                      <a:srgbClr val="C00000"/>
+                    </a:solidFill>
+                  </a:tcPr>
+                </a:tc>
+                <a:tc>
+                  <a:txBody>
+                    <a:bodyPr/>
+                    <a:lstStyle/>
+                    <a:p>
+                      <a:pPr algn="ctr">
+                        <a:defRPr b="1" sz="900">
+                          <a:solidFill>
+                            <a:srgbClr val="FFFFFF"/>
+                          </a:solidFill>
+                        </a:defRPr>
+                      </a:pPr>
+                      <a:r>
+                        <a:t>Total Kirim</a:t>
+                      </a:r>
+                    </a:p>
+                  </a:txBody>
+                  <a:tcPr>
+                    <a:solidFill>
+                      <a:srgbClr val="C00000"/>
+                    </a:solidFill>
+                  </a:tcPr>
+                </a:tc>
+                <a:tc>
+                  <a:txBody>
+                    <a:bodyPr/>
+                    <a:lstStyle/>
+                    <a:p>
+                      <a:pPr algn="ctr">
+                        <a:defRPr b="1" sz="900">
+                          <a:solidFill>
+                            <a:srgbClr val="FFFFFF"/>
+                          </a:solidFill>
+                        </a:defRPr>
+                      </a:pPr>
+                      <a:r>
+                        <a:t>Total Realisasi</a:t>
+                      </a:r>
+                    </a:p>
+                  </a:txBody>
+                  <a:tcPr>
+                    <a:solidFill>
+                      <a:srgbClr val="C00000"/>
+                    </a:solidFill>
+                  </a:tcPr>
+                </a:tc>
+                <a:tc>
+                  <a:txBody>
+                    <a:bodyPr/>
+                    <a:lstStyle/>
+                    <a:p>
+                      <a:pPr algn="ctr">
+                        <a:defRPr b="1" sz="900">
+                          <a:solidFill>
+                            <a:srgbClr val="FFFFFF"/>
+                          </a:solidFill>
+                        </a:defRPr>
+                      </a:pPr>
+                      <a:r>
+                        <a:t>SL Kirim (%)</a:t>
+                      </a:r>
+                    </a:p>
+                  </a:txBody>
+                  <a:tcPr>
+                    <a:solidFill>
+                      <a:srgbClr val="C00000"/>
+                    </a:solidFill>
+                  </a:tcPr>
+                </a:tc>
+                <a:tc>
+                  <a:txBody>
+                    <a:bodyPr/>
+                    <a:lstStyle/>
+                    <a:p>
+                      <a:pPr algn="ctr">
+                        <a:defRPr b="1" sz="900">
+                          <a:solidFill>
+                            <a:srgbClr val="FFFFFF"/>
+                          </a:solidFill>
+                        </a:defRPr>
+                      </a:pPr>
+                      <a:r>
+                        <a:t>SL Realisasi (%)</a:t>
+                      </a:r>
+                    </a:p>
+                  </a:txBody>
+                  <a:tcPr>
+                    <a:solidFill>
+                      <a:srgbClr val="C00000"/>
+                    </a:solidFill>
+                  </a:tcPr>
+                </a:tc>
+              </a:tr>
+              <a:tr h="248194">
+                <a:tc>
+                  <a:txBody>
+                    <a:bodyPr/>
+                    <a:lstStyle/>
+                    <a:p>
+                      <a:pPr algn="ctr">
+                        <a:defRPr sz="850"/>
+                      </a:pPr>
+                      <a:r>
+                        <a:t>JAN-2026</a:t>
+                      </a:r>
+                    </a:p>
+                  </a:txBody>
+                  <a:tcPr/>
+                </a:tc>
+                <a:tc>
+                  <a:txBody>
+                    <a:bodyPr/>
+                    <a:lstStyle/>
+                    <a:p>
+                      <a:pPr algn="r">
+                        <a:defRPr sz="850"/>
+                      </a:pPr>
+                      <a:r>
+                        <a:t>46,604,811,197</a:t>
+                      </a:r>
+                    </a:p>
+                  </a:txBody>
+                  <a:tcPr/>
+                </a:tc>
+                <a:tc>
+                  <a:txBody>
+                    <a:bodyPr/>
+                    <a:lstStyle/>
+                    <a:p>
+                      <a:pPr algn="r">
+                        <a:defRPr sz="850"/>
+                      </a:pPr>
+                      <a:r>
+                        <a:t>34,128,318,314</a:t>
+                      </a:r>
+                    </a:p>
+                  </a:txBody>
+                  <a:tcPr/>
+                </a:tc>
+                <a:tc>
+                  <a:txBody>
+                    <a:bodyPr/>
+                    <a:lstStyle/>
+                    <a:p>
+                      <a:pPr algn="r">
+                        <a:defRPr sz="850"/>
+                      </a:pPr>
+                      <a:r>
+                        <a:t>33,741,701,934</a:t>
+                      </a:r>
+                    </a:p>
+                  </a:txBody>
+                  <a:tcPr/>
+                </a:tc>
+                <a:tc>
+                  <a:txBody>
+                    <a:bodyPr/>
+                    <a:lstStyle/>
+                    <a:p>
+                      <a:pPr algn="r">
+                        <a:defRPr sz="850"/>
+                      </a:pPr>
+                      <a:r>
+                        <a:t>68.1%</a:t>
+                      </a:r>
+                    </a:p>
+                  </a:txBody>
+                  <a:tcPr/>
+                </a:tc>
+                <a:tc>
+                  <a:txBody>
+                    <a:bodyPr/>
+                    <a:lstStyle/>
+                    <a:p>
+                      <a:pPr algn="r">
+                        <a:defRPr sz="850"/>
+                      </a:pPr>
+                      <a:r>
+                        <a:t>67.7%</a:t>
+                      </a:r>
+                    </a:p>
+                  </a:txBody>
+                  <a:tcPr/>
+                </a:tc>
+              </a:tr>
+              <a:tr h="248194">
+                <a:tc>
+                  <a:txBody>
+                    <a:bodyPr/>
+                    <a:lstStyle/>
+                    <a:p>
+                      <a:pPr algn="ctr">
+                        <a:defRPr sz="850"/>
+                      </a:pPr>
+                      <a:r>
+                        <a:t>FEB-2026</a:t>
+                      </a:r>
+                    </a:p>
+                  </a:txBody>
+                  <a:tcPr/>
+                </a:tc>
+                <a:tc>
+                  <a:txBody>
+                    <a:bodyPr/>
+                    <a:lstStyle/>
+                    <a:p>
+                      <a:pPr algn="r">
+                        <a:defRPr sz="850"/>
+                      </a:pPr>
+                      <a:r>
+                        <a:t>36,571,847,722</a:t>
+                      </a:r>
+                    </a:p>
+                  </a:txBody>
+                  <a:tcPr/>
+                </a:tc>
+                <a:tc>
+                  <a:txBody>
+                    <a:bodyPr/>
+                    <a:lstStyle/>
+                    <a:p>
+                      <a:pPr algn="r">
+                        <a:defRPr sz="850"/>
+                      </a:pPr>
+                      <a:r>
+                        <a:t>28,202,025,600</a:t>
+                      </a:r>
+                    </a:p>
+                  </a:txBody>
+                  <a:tcPr/>
+                </a:tc>
+                <a:tc>
+                  <a:txBody>
+                    <a:bodyPr/>
+                    <a:lstStyle/>
+                    <a:p>
+                      <a:pPr algn="r">
+                        <a:defRPr sz="850"/>
+                      </a:pPr>
+                      <a:r>
+                        <a:t>27,868,163,336</a:t>
+                      </a:r>
+                    </a:p>
+                  </a:txBody>
+                  <a:tcPr/>
+                </a:tc>
+                <a:tc>
+                  <a:txBody>
+                    <a:bodyPr/>
+                    <a:lstStyle/>
+                    <a:p>
+                      <a:pPr algn="r">
+                        <a:defRPr sz="850"/>
+                      </a:pPr>
+                      <a:r>
+                        <a:t>71.2%</a:t>
+                      </a:r>
+                    </a:p>
+                  </a:txBody>
+                  <a:tcPr/>
+                </a:tc>
+                <a:tc>
+                  <a:txBody>
+                    <a:bodyPr/>
+                    <a:lstStyle/>
+                    <a:p>
+                      <a:pPr algn="r">
+                        <a:defRPr sz="850"/>
+                      </a:pPr>
+                      <a:r>
+                        <a:t>70.7%</a:t>
+                      </a:r>
+                    </a:p>
+                  </a:txBody>
+                  <a:tcPr/>
+                </a:tc>
+              </a:tr>
+              <a:tr h="248194">
+                <a:tc>
+                  <a:txBody>
+                    <a:bodyPr/>
+                    <a:lstStyle/>
+                    <a:p>
+                      <a:pPr algn="ctr">
+                        <a:defRPr sz="850"/>
+                      </a:pPr>
+                      <a:r>
+                        <a:t>MAR-2026</a:t>
+                      </a:r>
+                    </a:p>
+                  </a:txBody>
+                  <a:tcPr/>
+                </a:tc>
+                <a:tc>
+                  <a:txBody>
+                    <a:bodyPr/>
+                    <a:lstStyle/>
+                    <a:p>
+                      <a:pPr algn="r">
+                        <a:defRPr sz="850"/>
+                      </a:pPr>
+                      <a:r>
+                        <a:t>34,644,467,848</a:t>
+                      </a:r>
+                    </a:p>
+                  </a:txBody>
+                  <a:tcPr/>
+                </a:tc>
+                <a:tc>
+                  <a:txBody>
+                    <a:bodyPr/>
+                    <a:lstStyle/>
+                    <a:p>
+                      <a:pPr algn="r">
+                        <a:defRPr sz="850"/>
+                      </a:pPr>
+                      <a:r>
+                        <a:t>29,856,558,452</a:t>
+                      </a:r>
+                    </a:p>
+                  </a:txBody>
+                  <a:tcPr/>
+                </a:tc>
+                <a:tc>
+                  <a:txBody>
+                    <a:bodyPr/>
+                    <a:lstStyle/>
+                    <a:p>
+                      <a:pPr algn="r">
+                        <a:defRPr sz="850"/>
+                      </a:pPr>
+                      <a:r>
+                        <a:t>29,285,800,742</a:t>
+                      </a:r>
+                    </a:p>
+                  </a:txBody>
+                  <a:tcPr/>
+                </a:tc>
+                <a:tc>
+                  <a:txBody>
+                    <a:bodyPr/>
+                    <a:lstStyle/>
+                    <a:p>
+                      <a:pPr algn="r">
+                        <a:defRPr sz="850"/>
+                      </a:pPr>
+                      <a:r>
+                        <a:t>81.0%</a:t>
+                      </a:r>
+                    </a:p>
+                  </a:txBody>
+                  <a:tcPr/>
+                </a:tc>
+                <a:tc>
+                  <a:txBody>
+                    <a:bodyPr/>
+                    <a:lstStyle/>
+                    <a:p>
+                      <a:pPr algn="r">
+                        <a:defRPr sz="850"/>
+                      </a:pPr>
+                      <a:r>
+                        <a:t>79.8%</a:t>
+                      </a:r>
+                    </a:p>
+                  </a:txBody>
+                  <a:tcPr/>
+                </a:tc>
+              </a:tr>
+              <a:tr h="248194">
+                <a:tc>
+                  <a:txBody>
+                    <a:bodyPr/>
+                    <a:lstStyle/>
+                    <a:p>
+                      <a:pPr algn="ctr">
+                        <a:defRPr sz="850"/>
+                      </a:pPr>
+                      <a:r>
+                        <a:t>APR-2026</a:t>
+                      </a:r>
+                    </a:p>
+                  </a:txBody>
+                  <a:tcPr/>
+                </a:tc>
+                <a:tc>
+                  <a:txBody>
+                    <a:bodyPr/>
+                    <a:lstStyle/>
+                    <a:p>
+                      <a:pPr algn="r">
+                        <a:defRPr sz="850"/>
+                      </a:pPr>
+                      <a:r>
+                        <a:t>27,618,748,217</a:t>
+                      </a:r>
+                    </a:p>
+                  </a:txBody>
+                  <a:tcPr/>
+                </a:tc>
+                <a:tc>
+                  <a:txBody>
+                    <a:bodyPr/>
+                    <a:lstStyle/>
+                    <a:p>
+                      <a:pPr algn="r">
+                        <a:defRPr sz="850"/>
+                      </a:pPr>
+                      <a:r>
+                        <a:t>24,570,729,589</a:t>
+                      </a:r>
+                    </a:p>
+                  </a:txBody>
+                  <a:tcPr/>
+                </a:tc>
+                <a:tc>
+                  <a:txBody>
+                    <a:bodyPr/>
+                    <a:lstStyle/>
+                    <a:p>
+                      <a:pPr algn="r">
+                        <a:defRPr sz="850"/>
+                      </a:pPr>
+                      <a:r>
+                        <a:t>24,342,179,179</a:t>
+                      </a:r>
+                    </a:p>
+                  </a:txBody>
+                  <a:tcPr/>
+                </a:tc>
+                <a:tc>
+                  <a:txBody>
+                    <a:bodyPr/>
+                    <a:lstStyle/>
+                    <a:p>
+                      <a:pPr algn="r">
+                        <a:defRPr sz="850"/>
+                      </a:pPr>
+                      <a:r>
+                        <a:t>85.3%</a:t>
+                      </a:r>
+                    </a:p>
+                  </a:txBody>
+                  <a:tcPr/>
+                </a:tc>
+                <a:tc>
+                  <a:txBody>
+                    <a:bodyPr/>
+                    <a:lstStyle/>
+                    <a:p>
+                      <a:pPr algn="r">
+                        <a:defRPr sz="850"/>
+                      </a:pPr>
+                      <a:r>
+                        <a:t>84.8%</a:t>
+                      </a:r>
+                    </a:p>
+                  </a:txBody>
+                  <a:tcPr/>
+                </a:tc>
+              </a:tr>
+              <a:tr h="248194">
+                <a:tc>
+                  <a:txBody>
+                    <a:bodyPr/>
+                    <a:lstStyle/>
+                    <a:p>
+                      <a:pPr algn="ctr">
+                        <a:defRPr sz="850"/>
+                      </a:pPr>
+                      <a:r>
+                        <a:t>MEI-2026</a:t>
+                      </a:r>
+                    </a:p>
+                  </a:txBody>
+                  <a:tcPr/>
+                </a:tc>
+                <a:tc>
+                  <a:txBody>
+                    <a:bodyPr/>
+                    <a:lstStyle/>
+                    <a:p>
+                      <a:pPr algn="r">
+                        <a:defRPr sz="850"/>
+                      </a:pPr>
+                      <a:r>
+                        <a:t>27,104,057,928</a:t>
+                      </a:r>
+                    </a:p>
+                  </a:txBody>
+                  <a:tcPr/>
+                </a:tc>
+                <a:tc>
+                  <a:txBody>
+                    <a:bodyPr/>
+                    <a:lstStyle/>
+                    <a:p>
+                      <a:pPr algn="r">
+                        <a:defRPr sz="850"/>
+                      </a:pPr>
+                      <a:r>
+                        <a:t>24,597,847,420</a:t>
+                      </a:r>
+                    </a:p>
+                  </a:txBody>
+                  <a:tcPr/>
+                </a:tc>
+                <a:tc>
+                  <a:txBody>
+                    <a:bodyPr/>
+                    <a:lstStyle/>
+                    <a:p>
+                      <a:pPr algn="r">
+                        <a:defRPr sz="850"/>
+                      </a:pPr>
+                      <a:r>
+                        <a:t>24,416,006,470</a:t>
+                      </a:r>
+                    </a:p>
+                  </a:txBody>
+                  <a:tcPr/>
+                </a:tc>
+                <a:tc>
+                  <a:txBody>
+                    <a:bodyPr/>
+                    <a:lstStyle/>
+                    <a:p>
+                      <a:pPr algn="r">
+                        <a:defRPr sz="850"/>
+                      </a:pPr>
+                      <a:r>
+                        <a:t>87.7%</a:t>
+                      </a:r>
+                    </a:p>
+                  </a:txBody>
+                  <a:tcPr/>
+                </a:tc>
+                <a:tc>
+                  <a:txBody>
+                    <a:bodyPr/>
+                    <a:lstStyle/>
+                    <a:p>
+                      <a:pPr algn="r">
+                        <a:defRPr sz="850"/>
+                      </a:pPr>
+                      <a:r>
+                        <a:t>87.4%</a:t>
+                      </a:r>
+                    </a:p>
+                  </a:txBody>
+                  <a:tcPr/>
+                </a:tc>
+              </a:tr>
+              <a:tr h="248196">
+                <a:tc>
+                  <a:txBody>
+                    <a:bodyPr/>
+                    <a:lstStyle/>
+                    <a:p>
+                      <a:pPr algn="ctr">
+                        <a:defRPr sz="850"/>
+                      </a:pPr>
+                      <a:r>
+                        <a:t>JUN-2026</a:t>
+                      </a:r>
+                    </a:p>
+                  </a:txBody>
+                  <a:tcPr/>
+                </a:tc>
+                <a:tc>
+                  <a:txBody>
+                    <a:bodyPr/>
+                    <a:lstStyle/>
+                    <a:p>
+                      <a:pPr algn="r">
+                        <a:defRPr sz="850"/>
+                      </a:pPr>
+                      <a:r>
+                        <a:t>32,539,859,868</a:t>
+                      </a:r>
+                    </a:p>
+                  </a:txBody>
+                  <a:tcPr/>
+                </a:tc>
+                <a:tc>
+                  <a:txBody>
+                    <a:bodyPr/>
+                    <a:lstStyle/>
+                    <a:p>
+                      <a:pPr algn="r">
+                        <a:defRPr sz="850"/>
+                      </a:pPr>
+                      <a:r>
+                        <a:t>29,683,497,322</a:t>
+                      </a:r>
+                    </a:p>
+                  </a:txBody>
+                  <a:tcPr/>
+                </a:tc>
+                <a:tc>
+                  <a:txBody>
+                    <a:bodyPr/>
+                    <a:lstStyle/>
+                    <a:p>
+                      <a:pPr algn="r">
+                        <a:defRPr sz="850"/>
+                      </a:pPr>
+                      <a:r>
+                        <a:t>29,441,760,892</a:t>
+                      </a:r>
+                    </a:p>
+                  </a:txBody>
+                  <a:tcPr/>
+                </a:tc>
+                <a:tc>
+                  <a:txBody>
+                    <a:bodyPr/>
+                    <a:lstStyle/>
+                    <a:p>
+                      <a:pPr algn="r">
+                        <a:defRPr sz="850"/>
+                      </a:pPr>
+                      <a:r>
+                        <a:t>87.5%</a:t>
+                      </a:r>
+                    </a:p>
+                  </a:txBody>
+                  <a:tcPr/>
+                </a:tc>
+                <a:tc>
+                  <a:txBody>
+                    <a:bodyPr/>
+                    <a:lstStyle/>
+                    <a:p>
+                      <a:pPr algn="r">
+                        <a:defRPr sz="850"/>
+                      </a:pPr>
+                      <a:r>
+                        <a:t>87.0%</a:t>
+                      </a:r>
+                    </a:p>
+                  </a:txBody>
+                  <a:tcPr/>
+                </a:tc>
+              </a:tr>
+            </a:tbl>
+          </a:graphicData>
+        </a:graphic>
+      </p:graphicFrame>
     </p:spTree>
   </p:cSld>
   <p:clrMapOvr>

</xml_diff>